<commit_message>
docs: finalize portfolio presentation
</commit_message>
<xml_diff>
--- a/docs/presentation/invoice-manager-engineering-case-study.pptx
+++ b/docs/presentation/invoice-manager-engineering-case-study.pptx
@@ -2,21 +2,21 @@
 <file path=ppt/presentation.xml><?xml version="1.0" encoding="utf-8"?>
 <p:presentation xmlns:p="http://schemas.openxmlformats.org/presentationml/2006/main">
   <p:sldMasterIdLst>
-    <p:sldMasterId xmlns:r="http://schemas.openxmlformats.org/officeDocument/2006/relationships" id="2147483648" r:id="Rc1eca95800754a87"/>
+    <p:sldMasterId xmlns:r="http://schemas.openxmlformats.org/officeDocument/2006/relationships" id="2147483648" r:id="Rcbdbd639cfce4d07"/>
   </p:sldMasterIdLst>
   <p:notesMasterIdLst>
-    <p:notesMasterId xmlns:r="http://schemas.openxmlformats.org/officeDocument/2006/relationships" r:id="R50898be58cd94266"/>
+    <p:notesMasterId xmlns:r="http://schemas.openxmlformats.org/officeDocument/2006/relationships" r:id="R20854748620a4eba"/>
   </p:notesMasterIdLst>
   <p:sldIdLst>
-    <p:sldId xmlns:r="http://schemas.openxmlformats.org/officeDocument/2006/relationships" id="256" r:id="R6e0593365ef34ef4"/>
-    <p:sldId xmlns:r="http://schemas.openxmlformats.org/officeDocument/2006/relationships" id="257" r:id="R744d632159a74262"/>
-    <p:sldId xmlns:r="http://schemas.openxmlformats.org/officeDocument/2006/relationships" id="258" r:id="Rf7cfbfc586df43ca"/>
-    <p:sldId xmlns:r="http://schemas.openxmlformats.org/officeDocument/2006/relationships" id="259" r:id="R557ea06817104492"/>
-    <p:sldId xmlns:r="http://schemas.openxmlformats.org/officeDocument/2006/relationships" id="260" r:id="R3c819ca49eaa480f"/>
-    <p:sldId xmlns:r="http://schemas.openxmlformats.org/officeDocument/2006/relationships" id="261" r:id="R6a837671b38e40f6"/>
-    <p:sldId xmlns:r="http://schemas.openxmlformats.org/officeDocument/2006/relationships" id="262" r:id="R9be6a2cd8673459b"/>
-    <p:sldId xmlns:r="http://schemas.openxmlformats.org/officeDocument/2006/relationships" id="263" r:id="R27531a43cc804fdc"/>
-    <p:sldId xmlns:r="http://schemas.openxmlformats.org/officeDocument/2006/relationships" id="264" r:id="R61b5b34defa54e8e"/>
+    <p:sldId xmlns:r="http://schemas.openxmlformats.org/officeDocument/2006/relationships" id="256" r:id="R4fc1a75c82c041bb"/>
+    <p:sldId xmlns:r="http://schemas.openxmlformats.org/officeDocument/2006/relationships" id="257" r:id="R353f0e0bbd9e46f4"/>
+    <p:sldId xmlns:r="http://schemas.openxmlformats.org/officeDocument/2006/relationships" id="258" r:id="Re409f487fdfe41d8"/>
+    <p:sldId xmlns:r="http://schemas.openxmlformats.org/officeDocument/2006/relationships" id="259" r:id="R708edf85cdd64c67"/>
+    <p:sldId xmlns:r="http://schemas.openxmlformats.org/officeDocument/2006/relationships" id="260" r:id="R0e130459289d4a63"/>
+    <p:sldId xmlns:r="http://schemas.openxmlformats.org/officeDocument/2006/relationships" id="261" r:id="R8da75d355ca54b52"/>
+    <p:sldId xmlns:r="http://schemas.openxmlformats.org/officeDocument/2006/relationships" id="262" r:id="Rddd9d0306d1a4707"/>
+    <p:sldId xmlns:r="http://schemas.openxmlformats.org/officeDocument/2006/relationships" id="263" r:id="R44110dfdd83b428b"/>
+    <p:sldId xmlns:r="http://schemas.openxmlformats.org/officeDocument/2006/relationships" id="264" r:id="Ra3839e56fbf345f9"/>
   </p:sldIdLst>
   <p:sldSz cx="12192000" cy="6858000"/>
   <p:notesSz cx="6858000" cy="9144000"/>
@@ -1143,7 +1143,7 @@
   </p:cSld>
   <p:clrMap bg1="lt1" tx1="dk1" bg2="lt2" tx2="dk2" accent1="accent1" accent2="accent2" accent3="accent3" accent4="accent4" accent5="accent5" accent6="accent6" hlink="hlink" folHlink="folHlink"/>
   <p:sldLayoutIdLst>
-    <p:sldLayoutId xmlns:r="http://schemas.openxmlformats.org/officeDocument/2006/relationships" id="2147483649" r:id="Rfadfc8be964b48b9"/>
+    <p:sldLayoutId xmlns:r="http://schemas.openxmlformats.org/officeDocument/2006/relationships" id="2147483649" r:id="Rf02dde1895e4421b"/>
   </p:sldLayoutIdLst>
   <p:txStyles>
     <p:titleStyle>
@@ -1722,6 +1722,7 @@
           <a:lstStyle xmlns:a="http://schemas.openxmlformats.org/drawingml/2006/main"/>
           <a:p xmlns:a="http://schemas.openxmlformats.org/drawingml/2006/main">
             <a:pPr algn="l">
+              <a:buNone/>
               <a:defRPr sz="1125" b="1">
                 <a:solidFill>
                   <a:srgbClr val="345995"/>
@@ -1772,6 +1773,7 @@
           <a:lstStyle xmlns:a="http://schemas.openxmlformats.org/drawingml/2006/main"/>
           <a:p xmlns:a="http://schemas.openxmlformats.org/drawingml/2006/main">
             <a:pPr algn="l">
+              <a:buNone/>
               <a:defRPr sz="4200" b="1">
                 <a:solidFill>
                   <a:srgbClr val="202428"/>
@@ -1789,6 +1791,7 @@
           </a:p>
           <a:p xmlns:a="http://schemas.openxmlformats.org/drawingml/2006/main">
             <a:pPr algn="l">
+              <a:buNone/>
               <a:defRPr sz="4200" b="1">
                 <a:solidFill>
                   <a:srgbClr val="202428"/>
@@ -1839,6 +1842,7 @@
           <a:lstStyle xmlns:a="http://schemas.openxmlformats.org/drawingml/2006/main"/>
           <a:p xmlns:a="http://schemas.openxmlformats.org/drawingml/2006/main">
             <a:pPr algn="l">
+              <a:buNone/>
               <a:defRPr sz="1800" b="0">
                 <a:solidFill>
                   <a:srgbClr val="656B70"/>
@@ -1856,6 +1860,7 @@
           </a:p>
           <a:p xmlns:a="http://schemas.openxmlformats.org/drawingml/2006/main">
             <a:pPr algn="l">
+              <a:buNone/>
               <a:defRPr sz="1800" b="0">
                 <a:solidFill>
                   <a:srgbClr val="656B70"/>
@@ -1937,6 +1942,7 @@
           <a:lstStyle xmlns:a="http://schemas.openxmlformats.org/drawingml/2006/main"/>
           <a:p xmlns:a="http://schemas.openxmlformats.org/drawingml/2006/main">
             <a:pPr algn="l">
+              <a:buNone/>
               <a:defRPr sz="1350" b="1">
                 <a:solidFill>
                   <a:srgbClr val="202428"/>
@@ -1954,6 +1960,7 @@
           </a:p>
           <a:p xmlns:a="http://schemas.openxmlformats.org/drawingml/2006/main">
             <a:pPr algn="l">
+              <a:buNone/>
               <a:defRPr sz="1350" b="1">
                 <a:solidFill>
                   <a:srgbClr val="202428"/>
@@ -2004,6 +2011,7 @@
           <a:lstStyle xmlns:a="http://schemas.openxmlformats.org/drawingml/2006/main"/>
           <a:p xmlns:a="http://schemas.openxmlformats.org/drawingml/2006/main">
             <a:pPr algn="l">
+              <a:buNone/>
               <a:defRPr sz="1050" b="0">
                 <a:solidFill>
                   <a:srgbClr val="656B70"/>
@@ -2056,14 +2064,14 @@
       </p:sp>
       <p:pic>
         <p:nvPicPr>
-          <p:cNvPr id="22" name=""/>
+          <p:cNvPr id="24" name=""/>
           <p:cNvPicPr>
             <a:picLocks xmlns:a="http://schemas.openxmlformats.org/drawingml/2006/main" noChangeAspect="1"/>
           </p:cNvPicPr>
           <p:nvPr/>
         </p:nvPicPr>
         <p:blipFill>
-          <a:blip xmlns:r="http://schemas.openxmlformats.org/officeDocument/2006/relationships" xmlns:a="http://schemas.openxmlformats.org/drawingml/2006/main" r:embed="R80e662cdbfb347bc"/>
+          <a:blip xmlns:r="http://schemas.openxmlformats.org/officeDocument/2006/relationships" xmlns:a="http://schemas.openxmlformats.org/drawingml/2006/main" r:embed="Ra361bdfa6bf04188"/>
           <a:stretch xmlns:a="http://schemas.openxmlformats.org/drawingml/2006/main"/>
         </p:blipFill>
         <p:spPr>
@@ -2109,6 +2117,7 @@
           <a:lstStyle xmlns:a="http://schemas.openxmlformats.org/drawingml/2006/main"/>
           <a:p xmlns:a="http://schemas.openxmlformats.org/drawingml/2006/main">
             <a:pPr algn="l">
+              <a:buNone/>
               <a:defRPr sz="3000" b="1">
                 <a:solidFill>
                   <a:srgbClr val="345995"/>
@@ -2159,6 +2168,7 @@
           <a:lstStyle xmlns:a="http://schemas.openxmlformats.org/drawingml/2006/main"/>
           <a:p xmlns:a="http://schemas.openxmlformats.org/drawingml/2006/main">
             <a:pPr algn="l">
+              <a:buNone/>
               <a:defRPr sz="1125" b="0">
                 <a:solidFill>
                   <a:srgbClr val="656B70"/>
@@ -2209,6 +2219,7 @@
           <a:lstStyle xmlns:a="http://schemas.openxmlformats.org/drawingml/2006/main"/>
           <a:p xmlns:a="http://schemas.openxmlformats.org/drawingml/2006/main">
             <a:pPr algn="l">
+              <a:buNone/>
               <a:defRPr sz="3000" b="1">
                 <a:solidFill>
                   <a:srgbClr val="202428"/>
@@ -2259,6 +2270,7 @@
           <a:lstStyle xmlns:a="http://schemas.openxmlformats.org/drawingml/2006/main"/>
           <a:p xmlns:a="http://schemas.openxmlformats.org/drawingml/2006/main">
             <a:pPr algn="l">
+              <a:buNone/>
               <a:defRPr sz="1125" b="0">
                 <a:solidFill>
                   <a:srgbClr val="656B70"/>
@@ -2309,6 +2321,7 @@
           <a:lstStyle xmlns:a="http://schemas.openxmlformats.org/drawingml/2006/main"/>
           <a:p xmlns:a="http://schemas.openxmlformats.org/drawingml/2006/main">
             <a:pPr algn="l">
+              <a:buNone/>
               <a:defRPr sz="1950" b="1">
                 <a:solidFill>
                   <a:srgbClr val="3F6B58"/>
@@ -2359,6 +2372,7 @@
           <a:lstStyle xmlns:a="http://schemas.openxmlformats.org/drawingml/2006/main"/>
           <a:p xmlns:a="http://schemas.openxmlformats.org/drawingml/2006/main">
             <a:pPr algn="l">
+              <a:buNone/>
               <a:defRPr sz="1125" b="0">
                 <a:solidFill>
                   <a:srgbClr val="656B70"/>
@@ -2438,6 +2452,7 @@
           <a:lstStyle xmlns:a="http://schemas.openxmlformats.org/drawingml/2006/main"/>
           <a:p xmlns:a="http://schemas.openxmlformats.org/drawingml/2006/main">
             <a:pPr algn="l">
+              <a:buNone/>
               <a:defRPr sz="1200" b="1">
                 <a:solidFill>
                   <a:srgbClr val="345995"/>
@@ -2488,6 +2503,7 @@
           <a:lstStyle xmlns:a="http://schemas.openxmlformats.org/drawingml/2006/main"/>
           <a:p xmlns:a="http://schemas.openxmlformats.org/drawingml/2006/main">
             <a:pPr algn="l">
+              <a:buNone/>
               <a:defRPr sz="2850" b="1">
                 <a:solidFill>
                   <a:srgbClr val="202428"/>
@@ -2500,7 +2516,7 @@
                   <a:srgbClr val="202428"/>
                 </a:solidFill>
               </a:rPr>
-              <a:t>One workflow from quote to payment</a:t>
+              <a:t>One workflow from company setup to reporting</a:t>
             </a:r>
           </a:p>
         </p:txBody>
@@ -2538,6 +2554,7 @@
           <a:lstStyle xmlns:a="http://schemas.openxmlformats.org/drawingml/2006/main"/>
           <a:p xmlns:a="http://schemas.openxmlformats.org/drawingml/2006/main">
             <a:pPr algn="l">
+              <a:buNone/>
               <a:defRPr sz="1500" b="0">
                 <a:solidFill>
                   <a:srgbClr val="656B70"/>
@@ -2619,6 +2636,7 @@
           <a:lstStyle xmlns:a="http://schemas.openxmlformats.org/drawingml/2006/main"/>
           <a:p xmlns:a="http://schemas.openxmlformats.org/drawingml/2006/main">
             <a:pPr algn="l">
+              <a:buNone/>
               <a:defRPr sz="900" b="1">
                 <a:solidFill>
                   <a:srgbClr val="656B70"/>
@@ -2669,6 +2687,7 @@
           <a:lstStyle xmlns:a="http://schemas.openxmlformats.org/drawingml/2006/main"/>
           <a:p xmlns:a="http://schemas.openxmlformats.org/drawingml/2006/main">
             <a:pPr algn="r">
+              <a:buNone/>
               <a:defRPr sz="900" b="0">
                 <a:solidFill>
                   <a:srgbClr val="656B70"/>
@@ -2781,6 +2800,7 @@
           <a:lstStyle xmlns:a="http://schemas.openxmlformats.org/drawingml/2006/main"/>
           <a:p xmlns:a="http://schemas.openxmlformats.org/drawingml/2006/main">
             <a:pPr algn="l">
+              <a:buNone/>
               <a:defRPr sz="1350" b="1">
                 <a:solidFill>
                   <a:srgbClr val="345995"/>
@@ -2831,6 +2851,7 @@
           <a:lstStyle xmlns:a="http://schemas.openxmlformats.org/drawingml/2006/main"/>
           <a:p xmlns:a="http://schemas.openxmlformats.org/drawingml/2006/main">
             <a:pPr algn="l">
+              <a:buNone/>
               <a:defRPr sz="1950" b="1">
                 <a:solidFill>
                   <a:srgbClr val="202428"/>
@@ -2881,6 +2902,7 @@
           <a:lstStyle xmlns:a="http://schemas.openxmlformats.org/drawingml/2006/main"/>
           <a:p xmlns:a="http://schemas.openxmlformats.org/drawingml/2006/main">
             <a:pPr algn="l">
+              <a:buNone/>
               <a:defRPr sz="1275" b="0">
                 <a:solidFill>
                   <a:srgbClr val="656B70"/>
@@ -2962,6 +2984,7 @@
           <a:lstStyle xmlns:a="http://schemas.openxmlformats.org/drawingml/2006/main"/>
           <a:p xmlns:a="http://schemas.openxmlformats.org/drawingml/2006/main">
             <a:pPr algn="l">
+              <a:buNone/>
               <a:defRPr sz="1350" b="1">
                 <a:solidFill>
                   <a:srgbClr val="345995"/>
@@ -3012,6 +3035,7 @@
           <a:lstStyle xmlns:a="http://schemas.openxmlformats.org/drawingml/2006/main"/>
           <a:p xmlns:a="http://schemas.openxmlformats.org/drawingml/2006/main">
             <a:pPr algn="l">
+              <a:buNone/>
               <a:defRPr sz="1950" b="1">
                 <a:solidFill>
                   <a:srgbClr val="202428"/>
@@ -3062,6 +3086,7 @@
           <a:lstStyle xmlns:a="http://schemas.openxmlformats.org/drawingml/2006/main"/>
           <a:p xmlns:a="http://schemas.openxmlformats.org/drawingml/2006/main">
             <a:pPr algn="l">
+              <a:buNone/>
               <a:defRPr sz="1275" b="0">
                 <a:solidFill>
                   <a:srgbClr val="656B70"/>
@@ -3143,6 +3168,7 @@
           <a:lstStyle xmlns:a="http://schemas.openxmlformats.org/drawingml/2006/main"/>
           <a:p xmlns:a="http://schemas.openxmlformats.org/drawingml/2006/main">
             <a:pPr algn="l">
+              <a:buNone/>
               <a:defRPr sz="1350" b="1">
                 <a:solidFill>
                   <a:srgbClr val="345995"/>
@@ -3193,6 +3219,7 @@
           <a:lstStyle xmlns:a="http://schemas.openxmlformats.org/drawingml/2006/main"/>
           <a:p xmlns:a="http://schemas.openxmlformats.org/drawingml/2006/main">
             <a:pPr algn="l">
+              <a:buNone/>
               <a:defRPr sz="1950" b="1">
                 <a:solidFill>
                   <a:srgbClr val="202428"/>
@@ -3243,6 +3270,7 @@
           <a:lstStyle xmlns:a="http://schemas.openxmlformats.org/drawingml/2006/main"/>
           <a:p xmlns:a="http://schemas.openxmlformats.org/drawingml/2006/main">
             <a:pPr algn="l">
+              <a:buNone/>
               <a:defRPr sz="1275" b="0">
                 <a:solidFill>
                   <a:srgbClr val="656B70"/>
@@ -3324,6 +3352,7 @@
           <a:lstStyle xmlns:a="http://schemas.openxmlformats.org/drawingml/2006/main"/>
           <a:p xmlns:a="http://schemas.openxmlformats.org/drawingml/2006/main">
             <a:pPr algn="l">
+              <a:buNone/>
               <a:defRPr sz="1350" b="1">
                 <a:solidFill>
                   <a:srgbClr val="345995"/>
@@ -3374,6 +3403,7 @@
           <a:lstStyle xmlns:a="http://schemas.openxmlformats.org/drawingml/2006/main"/>
           <a:p xmlns:a="http://schemas.openxmlformats.org/drawingml/2006/main">
             <a:pPr algn="l">
+              <a:buNone/>
               <a:defRPr sz="1950" b="1">
                 <a:solidFill>
                   <a:srgbClr val="202428"/>
@@ -3424,6 +3454,7 @@
           <a:lstStyle xmlns:a="http://schemas.openxmlformats.org/drawingml/2006/main"/>
           <a:p xmlns:a="http://schemas.openxmlformats.org/drawingml/2006/main">
             <a:pPr algn="l">
+              <a:buNone/>
               <a:defRPr sz="1275" b="0">
                 <a:solidFill>
                   <a:srgbClr val="656B70"/>
@@ -3505,6 +3536,7 @@
           <a:lstStyle xmlns:a="http://schemas.openxmlformats.org/drawingml/2006/main"/>
           <a:p xmlns:a="http://schemas.openxmlformats.org/drawingml/2006/main">
             <a:pPr algn="l">
+              <a:buNone/>
               <a:defRPr sz="1350" b="1">
                 <a:solidFill>
                   <a:srgbClr val="345995"/>
@@ -3555,6 +3587,7 @@
           <a:lstStyle xmlns:a="http://schemas.openxmlformats.org/drawingml/2006/main"/>
           <a:p xmlns:a="http://schemas.openxmlformats.org/drawingml/2006/main">
             <a:pPr algn="l">
+              <a:buNone/>
               <a:defRPr sz="1950" b="1">
                 <a:solidFill>
                   <a:srgbClr val="202428"/>
@@ -3605,6 +3638,7 @@
           <a:lstStyle xmlns:a="http://schemas.openxmlformats.org/drawingml/2006/main"/>
           <a:p xmlns:a="http://schemas.openxmlformats.org/drawingml/2006/main">
             <a:pPr algn="l">
+              <a:buNone/>
               <a:defRPr sz="1275" b="0">
                 <a:solidFill>
                   <a:srgbClr val="656B70"/>
@@ -3686,6 +3720,7 @@
           <a:lstStyle xmlns:a="http://schemas.openxmlformats.org/drawingml/2006/main"/>
           <a:p xmlns:a="http://schemas.openxmlformats.org/drawingml/2006/main">
             <a:pPr algn="l">
+              <a:buNone/>
               <a:defRPr sz="1425" b="1">
                 <a:solidFill>
                   <a:srgbClr val="202428"/>
@@ -3765,6 +3800,7 @@
           <a:lstStyle xmlns:a="http://schemas.openxmlformats.org/drawingml/2006/main"/>
           <a:p xmlns:a="http://schemas.openxmlformats.org/drawingml/2006/main">
             <a:pPr algn="l">
+              <a:buNone/>
               <a:defRPr sz="1200" b="1">
                 <a:solidFill>
                   <a:srgbClr val="345995"/>
@@ -3815,6 +3851,7 @@
           <a:lstStyle xmlns:a="http://schemas.openxmlformats.org/drawingml/2006/main"/>
           <a:p xmlns:a="http://schemas.openxmlformats.org/drawingml/2006/main">
             <a:pPr algn="l">
+              <a:buNone/>
               <a:defRPr sz="2850" b="1">
                 <a:solidFill>
                   <a:srgbClr val="202428"/>
@@ -3865,6 +3902,7 @@
           <a:lstStyle xmlns:a="http://schemas.openxmlformats.org/drawingml/2006/main"/>
           <a:p xmlns:a="http://schemas.openxmlformats.org/drawingml/2006/main">
             <a:pPr algn="l">
+              <a:buNone/>
               <a:defRPr sz="1500" b="0">
                 <a:solidFill>
                   <a:srgbClr val="656B70"/>
@@ -3946,6 +3984,7 @@
           <a:lstStyle xmlns:a="http://schemas.openxmlformats.org/drawingml/2006/main"/>
           <a:p xmlns:a="http://schemas.openxmlformats.org/drawingml/2006/main">
             <a:pPr algn="l">
+              <a:buNone/>
               <a:defRPr sz="900" b="1">
                 <a:solidFill>
                   <a:srgbClr val="656B70"/>
@@ -3996,6 +4035,7 @@
           <a:lstStyle xmlns:a="http://schemas.openxmlformats.org/drawingml/2006/main"/>
           <a:p xmlns:a="http://schemas.openxmlformats.org/drawingml/2006/main">
             <a:pPr algn="r">
+              <a:buNone/>
               <a:defRPr sz="900" b="0">
                 <a:solidFill>
                   <a:srgbClr val="656B70"/>
@@ -4046,6 +4086,7 @@
           <a:lstStyle xmlns:a="http://schemas.openxmlformats.org/drawingml/2006/main"/>
           <a:p xmlns:a="http://schemas.openxmlformats.org/drawingml/2006/main">
             <a:pPr algn="l">
+              <a:buNone/>
               <a:defRPr sz="1350" b="1">
                 <a:solidFill>
                   <a:srgbClr val="345995"/>
@@ -4096,6 +4137,7 @@
           <a:lstStyle xmlns:a="http://schemas.openxmlformats.org/drawingml/2006/main"/>
           <a:p xmlns:a="http://schemas.openxmlformats.org/drawingml/2006/main">
             <a:pPr algn="l">
+              <a:buNone/>
               <a:defRPr sz="1875" b="1">
                 <a:solidFill>
                   <a:srgbClr val="202428"/>
@@ -4146,6 +4188,7 @@
           <a:lstStyle xmlns:a="http://schemas.openxmlformats.org/drawingml/2006/main"/>
           <a:p xmlns:a="http://schemas.openxmlformats.org/drawingml/2006/main">
             <a:pPr algn="l">
+              <a:buNone/>
               <a:defRPr sz="1350" b="0">
                 <a:solidFill>
                   <a:srgbClr val="656B70"/>
@@ -4227,6 +4270,7 @@
           <a:lstStyle xmlns:a="http://schemas.openxmlformats.org/drawingml/2006/main"/>
           <a:p xmlns:a="http://schemas.openxmlformats.org/drawingml/2006/main">
             <a:pPr algn="l">
+              <a:buNone/>
               <a:defRPr sz="1350" b="1">
                 <a:solidFill>
                   <a:srgbClr val="345995"/>
@@ -4277,6 +4321,7 @@
           <a:lstStyle xmlns:a="http://schemas.openxmlformats.org/drawingml/2006/main"/>
           <a:p xmlns:a="http://schemas.openxmlformats.org/drawingml/2006/main">
             <a:pPr algn="l">
+              <a:buNone/>
               <a:defRPr sz="1875" b="1">
                 <a:solidFill>
                   <a:srgbClr val="202428"/>
@@ -4327,6 +4372,7 @@
           <a:lstStyle xmlns:a="http://schemas.openxmlformats.org/drawingml/2006/main"/>
           <a:p xmlns:a="http://schemas.openxmlformats.org/drawingml/2006/main">
             <a:pPr algn="l">
+              <a:buNone/>
               <a:defRPr sz="1350" b="0">
                 <a:solidFill>
                   <a:srgbClr val="656B70"/>
@@ -4408,6 +4454,7 @@
           <a:lstStyle xmlns:a="http://schemas.openxmlformats.org/drawingml/2006/main"/>
           <a:p xmlns:a="http://schemas.openxmlformats.org/drawingml/2006/main">
             <a:pPr algn="l">
+              <a:buNone/>
               <a:defRPr sz="1350" b="1">
                 <a:solidFill>
                   <a:srgbClr val="345995"/>
@@ -4458,6 +4505,7 @@
           <a:lstStyle xmlns:a="http://schemas.openxmlformats.org/drawingml/2006/main"/>
           <a:p xmlns:a="http://schemas.openxmlformats.org/drawingml/2006/main">
             <a:pPr algn="l">
+              <a:buNone/>
               <a:defRPr sz="1875" b="1">
                 <a:solidFill>
                   <a:srgbClr val="202428"/>
@@ -4508,6 +4556,7 @@
           <a:lstStyle xmlns:a="http://schemas.openxmlformats.org/drawingml/2006/main"/>
           <a:p xmlns:a="http://schemas.openxmlformats.org/drawingml/2006/main">
             <a:pPr algn="l">
+              <a:buNone/>
               <a:defRPr sz="1350" b="0">
                 <a:solidFill>
                   <a:srgbClr val="656B70"/>
@@ -4589,6 +4638,7 @@
           <a:lstStyle xmlns:a="http://schemas.openxmlformats.org/drawingml/2006/main"/>
           <a:p xmlns:a="http://schemas.openxmlformats.org/drawingml/2006/main">
             <a:pPr algn="l">
+              <a:buNone/>
               <a:defRPr sz="1350" b="1">
                 <a:solidFill>
                   <a:srgbClr val="345995"/>
@@ -4639,6 +4689,7 @@
           <a:lstStyle xmlns:a="http://schemas.openxmlformats.org/drawingml/2006/main"/>
           <a:p xmlns:a="http://schemas.openxmlformats.org/drawingml/2006/main">
             <a:pPr algn="l">
+              <a:buNone/>
               <a:defRPr sz="1875" b="1">
                 <a:solidFill>
                   <a:srgbClr val="202428"/>
@@ -4689,6 +4740,7 @@
           <a:lstStyle xmlns:a="http://schemas.openxmlformats.org/drawingml/2006/main"/>
           <a:p xmlns:a="http://schemas.openxmlformats.org/drawingml/2006/main">
             <a:pPr algn="l">
+              <a:buNone/>
               <a:defRPr sz="1350" b="0">
                 <a:solidFill>
                   <a:srgbClr val="656B70"/>
@@ -4799,6 +4851,7 @@
           <a:lstStyle xmlns:a="http://schemas.openxmlformats.org/drawingml/2006/main"/>
           <a:p xmlns:a="http://schemas.openxmlformats.org/drawingml/2006/main">
             <a:pPr algn="l">
+              <a:buNone/>
               <a:defRPr sz="1200" b="1">
                 <a:solidFill>
                   <a:srgbClr val="345995"/>
@@ -4849,6 +4902,7 @@
           <a:lstStyle xmlns:a="http://schemas.openxmlformats.org/drawingml/2006/main"/>
           <a:p xmlns:a="http://schemas.openxmlformats.org/drawingml/2006/main">
             <a:pPr algn="l">
+              <a:buNone/>
               <a:defRPr sz="2850" b="1">
                 <a:solidFill>
                   <a:srgbClr val="202428"/>
@@ -4899,6 +4953,7 @@
           <a:lstStyle xmlns:a="http://schemas.openxmlformats.org/drawingml/2006/main"/>
           <a:p xmlns:a="http://schemas.openxmlformats.org/drawingml/2006/main">
             <a:pPr algn="l">
+              <a:buNone/>
               <a:defRPr sz="1500" b="0">
                 <a:solidFill>
                   <a:srgbClr val="656B70"/>
@@ -4980,6 +5035,7 @@
           <a:lstStyle xmlns:a="http://schemas.openxmlformats.org/drawingml/2006/main"/>
           <a:p xmlns:a="http://schemas.openxmlformats.org/drawingml/2006/main">
             <a:pPr algn="l">
+              <a:buNone/>
               <a:defRPr sz="900" b="1">
                 <a:solidFill>
                   <a:srgbClr val="656B70"/>
@@ -5030,6 +5086,7 @@
           <a:lstStyle xmlns:a="http://schemas.openxmlformats.org/drawingml/2006/main"/>
           <a:p xmlns:a="http://schemas.openxmlformats.org/drawingml/2006/main">
             <a:pPr algn="r">
+              <a:buNone/>
               <a:defRPr sz="900" b="0">
                 <a:solidFill>
                   <a:srgbClr val="656B70"/>
@@ -5175,6 +5232,7 @@
           <a:lstStyle xmlns:a="http://schemas.openxmlformats.org/drawingml/2006/main"/>
           <a:p xmlns:a="http://schemas.openxmlformats.org/drawingml/2006/main">
             <a:pPr algn="l">
+              <a:buNone/>
               <a:defRPr sz="1350" b="1">
                 <a:solidFill>
                   <a:srgbClr val="656B70"/>
@@ -5187,7 +5245,7 @@
                   <a:srgbClr val="656B70"/>
                 </a:solidFill>
               </a:rPr>
-              <a:t>APP</a:t>
+              <a:t>APP  →</a:t>
             </a:r>
           </a:p>
         </p:txBody>
@@ -5225,6 +5283,7 @@
           <a:lstStyle xmlns:a="http://schemas.openxmlformats.org/drawingml/2006/main"/>
           <a:p xmlns:a="http://schemas.openxmlformats.org/drawingml/2006/main">
             <a:pPr algn="l">
+              <a:buNone/>
               <a:defRPr sz="1500" b="1">
                 <a:solidFill>
                   <a:srgbClr val="202428"/>
@@ -5308,6 +5367,7 @@
           <a:lstStyle xmlns:a="http://schemas.openxmlformats.org/drawingml/2006/main"/>
           <a:p xmlns:a="http://schemas.openxmlformats.org/drawingml/2006/main">
             <a:pPr algn="l">
+              <a:buNone/>
               <a:defRPr sz="1350" b="1">
                 <a:solidFill>
                   <a:srgbClr val="656B70"/>
@@ -5320,7 +5380,7 @@
                   <a:srgbClr val="656B70"/>
                 </a:solidFill>
               </a:rPr>
-              <a:t>APPLICATION</a:t>
+              <a:t>APPLICATION  →</a:t>
             </a:r>
           </a:p>
         </p:txBody>
@@ -5358,6 +5418,7 @@
           <a:lstStyle xmlns:a="http://schemas.openxmlformats.org/drawingml/2006/main"/>
           <a:p xmlns:a="http://schemas.openxmlformats.org/drawingml/2006/main">
             <a:pPr algn="l">
+              <a:buNone/>
               <a:defRPr sz="1500" b="1">
                 <a:solidFill>
                   <a:srgbClr val="202428"/>
@@ -5441,6 +5502,7 @@
           <a:lstStyle xmlns:a="http://schemas.openxmlformats.org/drawingml/2006/main"/>
           <a:p xmlns:a="http://schemas.openxmlformats.org/drawingml/2006/main">
             <a:pPr algn="l">
+              <a:buNone/>
               <a:defRPr sz="1350" b="1">
                 <a:solidFill>
                   <a:srgbClr val="345995"/>
@@ -5491,6 +5553,7 @@
           <a:lstStyle xmlns:a="http://schemas.openxmlformats.org/drawingml/2006/main"/>
           <a:p xmlns:a="http://schemas.openxmlformats.org/drawingml/2006/main">
             <a:pPr algn="l">
+              <a:buNone/>
               <a:defRPr sz="1500" b="1">
                 <a:solidFill>
                   <a:srgbClr val="202428"/>
@@ -5557,36 +5620,37 @@
         </p:nvSpPr>
         <p:spPr>
           <a:xfrm xmlns:a="http://schemas.openxmlformats.org/drawingml/2006/main">
-            <a:off x="4857750" y="4953000"/>
-            <a:ext cx="1809750" cy="238125"/>
-          </a:xfrm>
-          <a:prstGeom xmlns:a="http://schemas.openxmlformats.org/drawingml/2006/main" prst="rect">
-            <a:avLst/>
-          </a:prstGeom>
-          <a:noFill xmlns:a="http://schemas.openxmlformats.org/drawingml/2006/main"/>
-          <a:ln xmlns:a="http://schemas.openxmlformats.org/drawingml/2006/main" w="0">
-            <a:noFill/>
-            <a:prstDash val="solid"/>
-          </a:ln>
-        </p:spPr>
-        <p:txBody>
-          <a:bodyPr xmlns:a="http://schemas.openxmlformats.org/drawingml/2006/main"/>
-          <a:lstStyle xmlns:a="http://schemas.openxmlformats.org/drawingml/2006/main"/>
-          <a:p xmlns:a="http://schemas.openxmlformats.org/drawingml/2006/main">
-            <a:pPr algn="l">
+            <a:off x="4857750" y="4914900"/>
+            <a:ext cx="4095750" cy="266700"/>
+          </a:xfrm>
+          <a:prstGeom xmlns:a="http://schemas.openxmlformats.org/drawingml/2006/main" prst="rect">
+            <a:avLst/>
+          </a:prstGeom>
+          <a:noFill xmlns:a="http://schemas.openxmlformats.org/drawingml/2006/main"/>
+          <a:ln xmlns:a="http://schemas.openxmlformats.org/drawingml/2006/main" w="0">
+            <a:noFill/>
+            <a:prstDash val="solid"/>
+          </a:ln>
+        </p:spPr>
+        <p:txBody>
+          <a:bodyPr xmlns:a="http://schemas.openxmlformats.org/drawingml/2006/main"/>
+          <a:lstStyle xmlns:a="http://schemas.openxmlformats.org/drawingml/2006/main"/>
+          <a:p xmlns:a="http://schemas.openxmlformats.org/drawingml/2006/main">
+            <a:pPr algn="l">
+              <a:buNone/>
               <a:defRPr sz="1125" b="1">
                 <a:solidFill>
-                  <a:srgbClr val="656B70"/>
+                  <a:srgbClr val="345995"/>
                 </a:solidFill>
               </a:defRPr>
             </a:pPr>
             <a:r>
               <a:rPr sz="1125" b="1">
                 <a:solidFill>
-                  <a:srgbClr val="656B70"/>
-                </a:solidFill>
-              </a:rPr>
-              <a:t>INFRASTRUCTURE</a:t>
+                  <a:srgbClr val="345995"/>
+                </a:solidFill>
+              </a:rPr>
+              <a:t>INFRASTRUCTURE  ·  implements ports ↑ APPLICATION</a:t>
             </a:r>
           </a:p>
         </p:txBody>
@@ -5624,6 +5688,7 @@
           <a:lstStyle xmlns:a="http://schemas.openxmlformats.org/drawingml/2006/main"/>
           <a:p xmlns:a="http://schemas.openxmlformats.org/drawingml/2006/main">
             <a:pPr algn="l">
+              <a:buNone/>
               <a:defRPr sz="1425" b="0">
                 <a:solidFill>
                   <a:srgbClr val="202428"/>
@@ -5674,6 +5739,7 @@
           <a:lstStyle xmlns:a="http://schemas.openxmlformats.org/drawingml/2006/main"/>
           <a:p xmlns:a="http://schemas.openxmlformats.org/drawingml/2006/main">
             <a:pPr algn="l">
+              <a:buNone/>
               <a:defRPr sz="1575" b="1">
                 <a:solidFill>
                   <a:srgbClr val="345995"/>
@@ -5753,6 +5819,7 @@
           <a:lstStyle xmlns:a="http://schemas.openxmlformats.org/drawingml/2006/main"/>
           <a:p xmlns:a="http://schemas.openxmlformats.org/drawingml/2006/main">
             <a:pPr algn="l">
+              <a:buNone/>
               <a:defRPr sz="1200" b="1">
                 <a:solidFill>
                   <a:srgbClr val="345995"/>
@@ -5803,6 +5870,7 @@
           <a:lstStyle xmlns:a="http://schemas.openxmlformats.org/drawingml/2006/main"/>
           <a:p xmlns:a="http://schemas.openxmlformats.org/drawingml/2006/main">
             <a:pPr algn="l">
+              <a:buNone/>
               <a:defRPr sz="2850" b="1">
                 <a:solidFill>
                   <a:srgbClr val="202428"/>
@@ -5884,6 +5952,7 @@
           <a:lstStyle xmlns:a="http://schemas.openxmlformats.org/drawingml/2006/main"/>
           <a:p xmlns:a="http://schemas.openxmlformats.org/drawingml/2006/main">
             <a:pPr algn="l">
+              <a:buNone/>
               <a:defRPr sz="900" b="1">
                 <a:solidFill>
                   <a:srgbClr val="656B70"/>
@@ -5934,6 +6003,7 @@
           <a:lstStyle xmlns:a="http://schemas.openxmlformats.org/drawingml/2006/main"/>
           <a:p xmlns:a="http://schemas.openxmlformats.org/drawingml/2006/main">
             <a:pPr algn="r">
+              <a:buNone/>
               <a:defRPr sz="900" b="0">
                 <a:solidFill>
                   <a:srgbClr val="656B70"/>
@@ -5986,14 +6056,14 @@
       </p:sp>
       <p:pic>
         <p:nvPicPr>
-          <p:cNvPr id="19" name=""/>
+          <p:cNvPr id="21" name=""/>
           <p:cNvPicPr>
             <a:picLocks xmlns:a="http://schemas.openxmlformats.org/drawingml/2006/main" noChangeAspect="1"/>
           </p:cNvPicPr>
           <p:nvPr/>
         </p:nvPicPr>
         <p:blipFill>
-          <a:blip xmlns:r="http://schemas.openxmlformats.org/officeDocument/2006/relationships" xmlns:a="http://schemas.openxmlformats.org/drawingml/2006/main" r:embed="R33f1899653cb408e"/>
+          <a:blip xmlns:r="http://schemas.openxmlformats.org/officeDocument/2006/relationships" xmlns:a="http://schemas.openxmlformats.org/drawingml/2006/main" r:embed="Reb88037ca98e46ba"/>
           <a:stretch xmlns:a="http://schemas.openxmlformats.org/drawingml/2006/main"/>
         </p:blipFill>
         <p:spPr>
@@ -6039,14 +6109,15 @@
           <a:lstStyle xmlns:a="http://schemas.openxmlformats.org/drawingml/2006/main"/>
           <a:p xmlns:a="http://schemas.openxmlformats.org/drawingml/2006/main">
             <a:pPr algn="l">
-              <a:defRPr sz="1200" b="0">
-                <a:solidFill>
-                  <a:srgbClr val="656B70"/>
-                </a:solidFill>
-              </a:defRPr>
-            </a:pPr>
-            <a:r>
-              <a:rPr sz="1200" b="0">
+              <a:buNone/>
+              <a:defRPr sz="1275" b="0">
+                <a:solidFill>
+                  <a:srgbClr val="656B70"/>
+                </a:solidFill>
+              </a:defRPr>
+            </a:pPr>
+            <a:r>
+              <a:rPr sz="1275" b="0">
                 <a:solidFill>
                   <a:srgbClr val="656B70"/>
                 </a:solidFill>
@@ -6089,6 +6160,7 @@
           <a:lstStyle xmlns:a="http://schemas.openxmlformats.org/drawingml/2006/main"/>
           <a:p xmlns:a="http://schemas.openxmlformats.org/drawingml/2006/main">
             <a:pPr algn="l">
+              <a:buNone/>
               <a:defRPr sz="1350" b="1">
                 <a:solidFill>
                   <a:srgbClr val="345995"/>
@@ -6139,6 +6211,7 @@
           <a:lstStyle xmlns:a="http://schemas.openxmlformats.org/drawingml/2006/main"/>
           <a:p xmlns:a="http://schemas.openxmlformats.org/drawingml/2006/main">
             <a:pPr algn="l">
+              <a:buNone/>
               <a:defRPr sz="1425" b="0">
                 <a:solidFill>
                   <a:srgbClr val="202428"/>
@@ -6161,6 +6234,7 @@
           </a:p>
           <a:p xmlns:a="http://schemas.openxmlformats.org/drawingml/2006/main">
             <a:pPr algn="l">
+              <a:buNone/>
               <a:defRPr sz="1425" b="0">
                 <a:solidFill>
                   <a:srgbClr val="202428"/>
@@ -6183,6 +6257,7 @@
           </a:p>
           <a:p xmlns:a="http://schemas.openxmlformats.org/drawingml/2006/main">
             <a:pPr algn="l">
+              <a:buNone/>
               <a:defRPr sz="1425" b="0">
                 <a:solidFill>
                   <a:srgbClr val="202428"/>
@@ -6205,6 +6280,7 @@
           </a:p>
           <a:p xmlns:a="http://schemas.openxmlformats.org/drawingml/2006/main">
             <a:pPr algn="l">
+              <a:buNone/>
               <a:defRPr sz="1425" b="0">
                 <a:solidFill>
                   <a:srgbClr val="202428"/>
@@ -6269,36 +6345,37 @@
         </p:nvSpPr>
         <p:spPr>
           <a:xfrm xmlns:a="http://schemas.openxmlformats.org/drawingml/2006/main">
-            <a:off x="8763000" y="5657850"/>
-            <a:ext cx="2714625" cy="552450"/>
-          </a:xfrm>
-          <a:prstGeom xmlns:a="http://schemas.openxmlformats.org/drawingml/2006/main" prst="rect">
-            <a:avLst/>
-          </a:prstGeom>
-          <a:noFill xmlns:a="http://schemas.openxmlformats.org/drawingml/2006/main"/>
-          <a:ln xmlns:a="http://schemas.openxmlformats.org/drawingml/2006/main" w="0">
-            <a:noFill/>
-            <a:prstDash val="solid"/>
-          </a:ln>
-        </p:spPr>
-        <p:txBody>
-          <a:bodyPr xmlns:a="http://schemas.openxmlformats.org/drawingml/2006/main"/>
-          <a:lstStyle xmlns:a="http://schemas.openxmlformats.org/drawingml/2006/main"/>
-          <a:p xmlns:a="http://schemas.openxmlformats.org/drawingml/2006/main">
-            <a:pPr algn="l">
-              <a:defRPr sz="1200" b="0">
-                <a:solidFill>
-                  <a:srgbClr val="656B70"/>
-                </a:solidFill>
-              </a:defRPr>
-            </a:pPr>
-            <a:r>
-              <a:rPr sz="1200" b="0">
-                <a:solidFill>
-                  <a:srgbClr val="656B70"/>
-                </a:solidFill>
-              </a:rPr>
-              <a:t>No reporting cache or sample-only calculation layer.</a:t>
+            <a:off x="8763000" y="5638800"/>
+            <a:ext cx="2714625" cy="590550"/>
+          </a:xfrm>
+          <a:prstGeom xmlns:a="http://schemas.openxmlformats.org/drawingml/2006/main" prst="rect">
+            <a:avLst/>
+          </a:prstGeom>
+          <a:noFill xmlns:a="http://schemas.openxmlformats.org/drawingml/2006/main"/>
+          <a:ln xmlns:a="http://schemas.openxmlformats.org/drawingml/2006/main" w="0">
+            <a:noFill/>
+            <a:prstDash val="solid"/>
+          </a:ln>
+        </p:spPr>
+        <p:txBody>
+          <a:bodyPr xmlns:a="http://schemas.openxmlformats.org/drawingml/2006/main"/>
+          <a:lstStyle xmlns:a="http://schemas.openxmlformats.org/drawingml/2006/main"/>
+          <a:p xmlns:a="http://schemas.openxmlformats.org/drawingml/2006/main">
+            <a:pPr algn="l">
+              <a:buNone/>
+              <a:defRPr sz="1275" b="0">
+                <a:solidFill>
+                  <a:srgbClr val="656B70"/>
+                </a:solidFill>
+              </a:defRPr>
+            </a:pPr>
+            <a:r>
+              <a:rPr sz="1275" b="0">
+                <a:solidFill>
+                  <a:srgbClr val="656B70"/>
+                </a:solidFill>
+              </a:rPr>
+              <a:t>KPIs are calculated from recorded payments and current invoice balances.</a:t>
             </a:r>
           </a:p>
         </p:txBody>
@@ -6365,6 +6442,7 @@
           <a:lstStyle xmlns:a="http://schemas.openxmlformats.org/drawingml/2006/main"/>
           <a:p xmlns:a="http://schemas.openxmlformats.org/drawingml/2006/main">
             <a:pPr algn="l">
+              <a:buNone/>
               <a:defRPr sz="1200" b="1">
                 <a:solidFill>
                   <a:srgbClr val="345995"/>
@@ -6415,6 +6493,7 @@
           <a:lstStyle xmlns:a="http://schemas.openxmlformats.org/drawingml/2006/main"/>
           <a:p xmlns:a="http://schemas.openxmlformats.org/drawingml/2006/main">
             <a:pPr algn="l">
+              <a:buNone/>
               <a:defRPr sz="2850" b="1">
                 <a:solidFill>
                   <a:srgbClr val="202428"/>
@@ -6496,6 +6575,7 @@
           <a:lstStyle xmlns:a="http://schemas.openxmlformats.org/drawingml/2006/main"/>
           <a:p xmlns:a="http://schemas.openxmlformats.org/drawingml/2006/main">
             <a:pPr algn="l">
+              <a:buNone/>
               <a:defRPr sz="900" b="1">
                 <a:solidFill>
                   <a:srgbClr val="656B70"/>
@@ -6546,6 +6626,7 @@
           <a:lstStyle xmlns:a="http://schemas.openxmlformats.org/drawingml/2006/main"/>
           <a:p xmlns:a="http://schemas.openxmlformats.org/drawingml/2006/main">
             <a:pPr algn="r">
+              <a:buNone/>
               <a:defRPr sz="900" b="0">
                 <a:solidFill>
                   <a:srgbClr val="656B70"/>
@@ -6598,15 +6679,15 @@
       </p:sp>
       <p:pic>
         <p:nvPicPr>
-          <p:cNvPr id="16" name=""/>
+          <p:cNvPr id="18" name=""/>
           <p:cNvPicPr>
             <a:picLocks xmlns:a="http://schemas.openxmlformats.org/drawingml/2006/main" noChangeAspect="1"/>
           </p:cNvPicPr>
           <p:nvPr/>
         </p:nvPicPr>
         <p:blipFill>
-          <a:blip xmlns:r="http://schemas.openxmlformats.org/officeDocument/2006/relationships" xmlns:a="http://schemas.openxmlformats.org/drawingml/2006/main" r:embed="R003c9174ea9d4c7e"/>
-          <a:srcRect xmlns:a="http://schemas.openxmlformats.org/drawingml/2006/main" l="0" t="7443" r="0" b="7443"/>
+          <a:blip xmlns:r="http://schemas.openxmlformats.org/officeDocument/2006/relationships" xmlns:a="http://schemas.openxmlformats.org/drawingml/2006/main" r:embed="Rc715718d44d4496b"/>
+          <a:srcRect xmlns:a="http://schemas.openxmlformats.org/drawingml/2006/main" l="12000" t="6000" r="1000" b="1000"/>
           <a:stretch xmlns:a="http://schemas.openxmlformats.org/drawingml/2006/main">
             <a:fillRect l="0" t="0" r="0" b="0"/>
           </a:stretch>
@@ -6654,6 +6735,7 @@
           <a:lstStyle xmlns:a="http://schemas.openxmlformats.org/drawingml/2006/main"/>
           <a:p xmlns:a="http://schemas.openxmlformats.org/drawingml/2006/main">
             <a:pPr algn="l">
+              <a:buNone/>
               <a:defRPr sz="1350" b="1">
                 <a:solidFill>
                   <a:srgbClr val="345995"/>
@@ -6704,14 +6786,15 @@
           <a:lstStyle xmlns:a="http://schemas.openxmlformats.org/drawingml/2006/main"/>
           <a:p xmlns:a="http://schemas.openxmlformats.org/drawingml/2006/main">
             <a:pPr algn="l">
-              <a:defRPr sz="1350" b="0">
+              <a:buNone/>
+              <a:defRPr sz="1425" b="0">
                 <a:solidFill>
                   <a:srgbClr val="202428"/>
                 </a:solidFill>
               </a:defRPr>
             </a:pPr>
             <a:r>
-              <a:rPr sz="1350" b="0">
+              <a:rPr sz="1425" b="0">
                 <a:solidFill>
                   <a:srgbClr val="202428"/>
                 </a:solidFill>
@@ -6726,14 +6809,15 @@
           </a:p>
           <a:p xmlns:a="http://schemas.openxmlformats.org/drawingml/2006/main">
             <a:pPr algn="l">
-              <a:defRPr sz="1350" b="0">
+              <a:buNone/>
+              <a:defRPr sz="1425" b="0">
                 <a:solidFill>
                   <a:srgbClr val="202428"/>
                 </a:solidFill>
               </a:defRPr>
             </a:pPr>
             <a:r>
-              <a:rPr sz="1350" b="0">
+              <a:rPr sz="1425" b="0">
                 <a:solidFill>
                   <a:srgbClr val="202428"/>
                 </a:solidFill>
@@ -6748,14 +6832,15 @@
           </a:p>
           <a:p xmlns:a="http://schemas.openxmlformats.org/drawingml/2006/main">
             <a:pPr algn="l">
-              <a:defRPr sz="1350" b="0">
+              <a:buNone/>
+              <a:defRPr sz="1425" b="0">
                 <a:solidFill>
                   <a:srgbClr val="202428"/>
                 </a:solidFill>
               </a:defRPr>
             </a:pPr>
             <a:r>
-              <a:rPr sz="1350" b="0">
+              <a:rPr sz="1425" b="0">
                 <a:solidFill>
                   <a:srgbClr val="202428"/>
                 </a:solidFill>
@@ -6770,14 +6855,15 @@
           </a:p>
           <a:p xmlns:a="http://schemas.openxmlformats.org/drawingml/2006/main">
             <a:pPr algn="l">
-              <a:defRPr sz="1350" b="0">
+              <a:buNone/>
+              <a:defRPr sz="1425" b="0">
                 <a:solidFill>
                   <a:srgbClr val="202428"/>
                 </a:solidFill>
               </a:defRPr>
             </a:pPr>
             <a:r>
-              <a:rPr sz="1350" b="0">
+              <a:rPr sz="1425" b="0">
                 <a:solidFill>
                   <a:srgbClr val="202428"/>
                 </a:solidFill>
@@ -6792,14 +6878,15 @@
           </a:p>
           <a:p xmlns:a="http://schemas.openxmlformats.org/drawingml/2006/main">
             <a:pPr algn="l">
-              <a:defRPr sz="1350" b="0">
+              <a:buNone/>
+              <a:defRPr sz="1425" b="0">
                 <a:solidFill>
                   <a:srgbClr val="202428"/>
                 </a:solidFill>
               </a:defRPr>
             </a:pPr>
             <a:r>
-              <a:rPr sz="1350" b="0">
+              <a:rPr sz="1425" b="0">
                 <a:solidFill>
                   <a:srgbClr val="202428"/>
                 </a:solidFill>
@@ -6871,6 +6958,7 @@
           <a:lstStyle xmlns:a="http://schemas.openxmlformats.org/drawingml/2006/main"/>
           <a:p xmlns:a="http://schemas.openxmlformats.org/drawingml/2006/main">
             <a:pPr algn="l">
+              <a:buNone/>
               <a:defRPr sz="1200" b="1">
                 <a:solidFill>
                   <a:srgbClr val="345995"/>
@@ -6921,6 +7009,7 @@
           <a:lstStyle xmlns:a="http://schemas.openxmlformats.org/drawingml/2006/main"/>
           <a:p xmlns:a="http://schemas.openxmlformats.org/drawingml/2006/main">
             <a:pPr algn="l">
+              <a:buNone/>
               <a:defRPr sz="2850" b="1">
                 <a:solidFill>
                   <a:srgbClr val="202428"/>
@@ -6971,6 +7060,7 @@
           <a:lstStyle xmlns:a="http://schemas.openxmlformats.org/drawingml/2006/main"/>
           <a:p xmlns:a="http://schemas.openxmlformats.org/drawingml/2006/main">
             <a:pPr algn="l">
+              <a:buNone/>
               <a:defRPr sz="1500" b="0">
                 <a:solidFill>
                   <a:srgbClr val="656B70"/>
@@ -7052,6 +7142,7 @@
           <a:lstStyle xmlns:a="http://schemas.openxmlformats.org/drawingml/2006/main"/>
           <a:p xmlns:a="http://schemas.openxmlformats.org/drawingml/2006/main">
             <a:pPr algn="l">
+              <a:buNone/>
               <a:defRPr sz="900" b="1">
                 <a:solidFill>
                   <a:srgbClr val="656B70"/>
@@ -7102,6 +7193,7 @@
           <a:lstStyle xmlns:a="http://schemas.openxmlformats.org/drawingml/2006/main"/>
           <a:p xmlns:a="http://schemas.openxmlformats.org/drawingml/2006/main">
             <a:pPr algn="r">
+              <a:buNone/>
               <a:defRPr sz="900" b="0">
                 <a:solidFill>
                   <a:srgbClr val="656B70"/>
@@ -7135,8 +7227,8 @@
         </p:nvSpPr>
         <p:spPr>
           <a:xfrm xmlns:a="http://schemas.openxmlformats.org/drawingml/2006/main">
-            <a:off x="838200" y="2038350"/>
-            <a:ext cx="4476750" cy="4171950"/>
+            <a:off x="742950" y="2000250"/>
+            <a:ext cx="4762500" cy="4248150"/>
           </a:xfrm>
           <a:prstGeom xmlns:a="http://schemas.openxmlformats.org/drawingml/2006/main" prst="rect">
             <a:avLst/>
@@ -7154,20 +7246,21 @@
       </p:sp>
       <p:pic>
         <p:nvPicPr>
-          <p:cNvPr id="30" name=""/>
+          <p:cNvPr id="32" name=""/>
           <p:cNvPicPr>
             <a:picLocks xmlns:a="http://schemas.openxmlformats.org/drawingml/2006/main" noChangeAspect="1"/>
           </p:cNvPicPr>
           <p:nvPr/>
         </p:nvPicPr>
         <p:blipFill>
-          <a:blip xmlns:r="http://schemas.openxmlformats.org/officeDocument/2006/relationships" xmlns:a="http://schemas.openxmlformats.org/drawingml/2006/main" r:embed="Rdee9a122a54f463a"/>
+          <a:blip xmlns:r="http://schemas.openxmlformats.org/officeDocument/2006/relationships" xmlns:a="http://schemas.openxmlformats.org/drawingml/2006/main" r:embed="R482f72d513464761"/>
+          <a:srcRect xmlns:a="http://schemas.openxmlformats.org/drawingml/2006/main" l="0" t="0" r="0" b="0"/>
           <a:stretch xmlns:a="http://schemas.openxmlformats.org/drawingml/2006/main"/>
         </p:blipFill>
         <p:spPr>
           <a:xfrm xmlns:a="http://schemas.openxmlformats.org/drawingml/2006/main">
-            <a:off x="971550" y="2341844"/>
-            <a:ext cx="4210050" cy="3564962"/>
+            <a:off x="809625" y="2124075"/>
+            <a:ext cx="4629150" cy="3952875"/>
           </a:xfrm>
           <a:prstGeom xmlns:a="http://schemas.openxmlformats.org/drawingml/2006/main" prst="rect">
             <a:avLst/>
@@ -7207,6 +7300,7 @@
           <a:lstStyle xmlns:a="http://schemas.openxmlformats.org/drawingml/2006/main"/>
           <a:p xmlns:a="http://schemas.openxmlformats.org/drawingml/2006/main">
             <a:pPr algn="l">
+              <a:buNone/>
               <a:defRPr sz="1350" b="0">
                 <a:solidFill>
                   <a:srgbClr val="656B70"/>
@@ -7257,6 +7351,7 @@
           <a:lstStyle xmlns:a="http://schemas.openxmlformats.org/drawingml/2006/main"/>
           <a:p xmlns:a="http://schemas.openxmlformats.org/drawingml/2006/main">
             <a:pPr algn="l">
+              <a:buNone/>
               <a:defRPr sz="1350" b="1">
                 <a:solidFill>
                   <a:srgbClr val="3F6B58"/>
@@ -7338,6 +7433,7 @@
           <a:lstStyle xmlns:a="http://schemas.openxmlformats.org/drawingml/2006/main"/>
           <a:p xmlns:a="http://schemas.openxmlformats.org/drawingml/2006/main">
             <a:pPr algn="l">
+              <a:buNone/>
               <a:defRPr sz="1350" b="0">
                 <a:solidFill>
                   <a:srgbClr val="656B70"/>
@@ -7388,6 +7484,7 @@
           <a:lstStyle xmlns:a="http://schemas.openxmlformats.org/drawingml/2006/main"/>
           <a:p xmlns:a="http://schemas.openxmlformats.org/drawingml/2006/main">
             <a:pPr algn="l">
+              <a:buNone/>
               <a:defRPr sz="1350" b="1">
                 <a:solidFill>
                   <a:srgbClr val="3F6B58"/>
@@ -7469,6 +7566,7 @@
           <a:lstStyle xmlns:a="http://schemas.openxmlformats.org/drawingml/2006/main"/>
           <a:p xmlns:a="http://schemas.openxmlformats.org/drawingml/2006/main">
             <a:pPr algn="l">
+              <a:buNone/>
               <a:defRPr sz="1350" b="0">
                 <a:solidFill>
                   <a:srgbClr val="656B70"/>
@@ -7519,6 +7617,7 @@
           <a:lstStyle xmlns:a="http://schemas.openxmlformats.org/drawingml/2006/main"/>
           <a:p xmlns:a="http://schemas.openxmlformats.org/drawingml/2006/main">
             <a:pPr algn="l">
+              <a:buNone/>
               <a:defRPr sz="1350" b="1">
                 <a:solidFill>
                   <a:srgbClr val="3F6B58"/>
@@ -7600,6 +7699,7 @@
           <a:lstStyle xmlns:a="http://schemas.openxmlformats.org/drawingml/2006/main"/>
           <a:p xmlns:a="http://schemas.openxmlformats.org/drawingml/2006/main">
             <a:pPr algn="l">
+              <a:buNone/>
               <a:defRPr sz="1350" b="0">
                 <a:solidFill>
                   <a:srgbClr val="656B70"/>
@@ -7650,6 +7750,7 @@
           <a:lstStyle xmlns:a="http://schemas.openxmlformats.org/drawingml/2006/main"/>
           <a:p xmlns:a="http://schemas.openxmlformats.org/drawingml/2006/main">
             <a:pPr algn="l">
+              <a:buNone/>
               <a:defRPr sz="1350" b="1">
                 <a:solidFill>
                   <a:srgbClr val="3F6B58"/>
@@ -7731,6 +7832,7 @@
           <a:lstStyle xmlns:a="http://schemas.openxmlformats.org/drawingml/2006/main"/>
           <a:p xmlns:a="http://schemas.openxmlformats.org/drawingml/2006/main">
             <a:pPr algn="l">
+              <a:buNone/>
               <a:defRPr sz="1200" b="1">
                 <a:solidFill>
                   <a:srgbClr val="345995"/>
@@ -7781,6 +7883,7 @@
           <a:lstStyle xmlns:a="http://schemas.openxmlformats.org/drawingml/2006/main"/>
           <a:p xmlns:a="http://schemas.openxmlformats.org/drawingml/2006/main">
             <a:pPr algn="l">
+              <a:buNone/>
               <a:defRPr sz="1500" b="0">
                 <a:solidFill>
                   <a:srgbClr val="202428"/>
@@ -7860,6 +7963,7 @@
           <a:lstStyle xmlns:a="http://schemas.openxmlformats.org/drawingml/2006/main"/>
           <a:p xmlns:a="http://schemas.openxmlformats.org/drawingml/2006/main">
             <a:pPr algn="l">
+              <a:buNone/>
               <a:defRPr sz="1200" b="1">
                 <a:solidFill>
                   <a:srgbClr val="345995"/>
@@ -7910,6 +8014,7 @@
           <a:lstStyle xmlns:a="http://schemas.openxmlformats.org/drawingml/2006/main"/>
           <a:p xmlns:a="http://schemas.openxmlformats.org/drawingml/2006/main">
             <a:pPr algn="l">
+              <a:buNone/>
               <a:defRPr sz="2850" b="1">
                 <a:solidFill>
                   <a:srgbClr val="202428"/>
@@ -7960,6 +8065,7 @@
           <a:lstStyle xmlns:a="http://schemas.openxmlformats.org/drawingml/2006/main"/>
           <a:p xmlns:a="http://schemas.openxmlformats.org/drawingml/2006/main">
             <a:pPr algn="l">
+              <a:buNone/>
               <a:defRPr sz="1500" b="0">
                 <a:solidFill>
                   <a:srgbClr val="656B70"/>
@@ -8041,6 +8147,7 @@
           <a:lstStyle xmlns:a="http://schemas.openxmlformats.org/drawingml/2006/main"/>
           <a:p xmlns:a="http://schemas.openxmlformats.org/drawingml/2006/main">
             <a:pPr algn="l">
+              <a:buNone/>
               <a:defRPr sz="900" b="1">
                 <a:solidFill>
                   <a:srgbClr val="656B70"/>
@@ -8091,6 +8198,7 @@
           <a:lstStyle xmlns:a="http://schemas.openxmlformats.org/drawingml/2006/main"/>
           <a:p xmlns:a="http://schemas.openxmlformats.org/drawingml/2006/main">
             <a:pPr algn="r">
+              <a:buNone/>
               <a:defRPr sz="900" b="0">
                 <a:solidFill>
                   <a:srgbClr val="656B70"/>
@@ -8141,6 +8249,7 @@
           <a:lstStyle xmlns:a="http://schemas.openxmlformats.org/drawingml/2006/main"/>
           <a:p xmlns:a="http://schemas.openxmlformats.org/drawingml/2006/main">
             <a:pPr algn="l">
+              <a:buNone/>
               <a:defRPr sz="5100" b="1">
                 <a:solidFill>
                   <a:srgbClr val="345995"/>
@@ -8191,6 +8300,7 @@
           <a:lstStyle xmlns:a="http://schemas.openxmlformats.org/drawingml/2006/main"/>
           <a:p xmlns:a="http://schemas.openxmlformats.org/drawingml/2006/main">
             <a:pPr algn="l">
+              <a:buNone/>
               <a:defRPr sz="1350" b="0">
                 <a:solidFill>
                   <a:srgbClr val="656B70"/>
@@ -8272,6 +8382,7 @@
           <a:lstStyle xmlns:a="http://schemas.openxmlformats.org/drawingml/2006/main"/>
           <a:p xmlns:a="http://schemas.openxmlformats.org/drawingml/2006/main">
             <a:pPr algn="l">
+              <a:buNone/>
               <a:defRPr sz="5100" b="1">
                 <a:solidFill>
                   <a:srgbClr val="202428"/>
@@ -8322,6 +8433,7 @@
           <a:lstStyle xmlns:a="http://schemas.openxmlformats.org/drawingml/2006/main"/>
           <a:p xmlns:a="http://schemas.openxmlformats.org/drawingml/2006/main">
             <a:pPr algn="l">
+              <a:buNone/>
               <a:defRPr sz="1350" b="0">
                 <a:solidFill>
                   <a:srgbClr val="656B70"/>
@@ -8403,6 +8515,7 @@
           <a:lstStyle xmlns:a="http://schemas.openxmlformats.org/drawingml/2006/main"/>
           <a:p xmlns:a="http://schemas.openxmlformats.org/drawingml/2006/main">
             <a:pPr algn="l">
+              <a:buNone/>
               <a:defRPr sz="5100" b="1">
                 <a:solidFill>
                   <a:srgbClr val="202428"/>
@@ -8453,6 +8566,7 @@
           <a:lstStyle xmlns:a="http://schemas.openxmlformats.org/drawingml/2006/main"/>
           <a:p xmlns:a="http://schemas.openxmlformats.org/drawingml/2006/main">
             <a:pPr algn="l">
+              <a:buNone/>
               <a:defRPr sz="1350" b="0">
                 <a:solidFill>
                   <a:srgbClr val="656B70"/>
@@ -8534,6 +8648,7 @@
           <a:lstStyle xmlns:a="http://schemas.openxmlformats.org/drawingml/2006/main"/>
           <a:p xmlns:a="http://schemas.openxmlformats.org/drawingml/2006/main">
             <a:pPr algn="l">
+              <a:buNone/>
               <a:defRPr sz="5100" b="1">
                 <a:solidFill>
                   <a:srgbClr val="3F6B58"/>
@@ -8584,6 +8699,7 @@
           <a:lstStyle xmlns:a="http://schemas.openxmlformats.org/drawingml/2006/main"/>
           <a:p xmlns:a="http://schemas.openxmlformats.org/drawingml/2006/main">
             <a:pPr algn="l">
+              <a:buNone/>
               <a:defRPr sz="1350" b="0">
                 <a:solidFill>
                   <a:srgbClr val="656B70"/>
@@ -8665,6 +8781,7 @@
           <a:lstStyle xmlns:a="http://schemas.openxmlformats.org/drawingml/2006/main"/>
           <a:p xmlns:a="http://schemas.openxmlformats.org/drawingml/2006/main">
             <a:pPr algn="l">
+              <a:buNone/>
               <a:defRPr sz="1425" b="1">
                 <a:solidFill>
                   <a:srgbClr val="202428"/>
@@ -8715,6 +8832,7 @@
           <a:lstStyle xmlns:a="http://schemas.openxmlformats.org/drawingml/2006/main"/>
           <a:p xmlns:a="http://schemas.openxmlformats.org/drawingml/2006/main">
             <a:pPr algn="l">
+              <a:buNone/>
               <a:defRPr sz="1425" b="1">
                 <a:solidFill>
                   <a:srgbClr val="202428"/>
@@ -8765,6 +8883,7 @@
           <a:lstStyle xmlns:a="http://schemas.openxmlformats.org/drawingml/2006/main"/>
           <a:p xmlns:a="http://schemas.openxmlformats.org/drawingml/2006/main">
             <a:pPr algn="l">
+              <a:buNone/>
               <a:defRPr sz="1425" b="1">
                 <a:solidFill>
                   <a:srgbClr val="202428"/>
@@ -8815,6 +8934,7 @@
           <a:lstStyle xmlns:a="http://schemas.openxmlformats.org/drawingml/2006/main"/>
           <a:p xmlns:a="http://schemas.openxmlformats.org/drawingml/2006/main">
             <a:pPr algn="l">
+              <a:buNone/>
               <a:defRPr sz="1350" b="0">
                 <a:solidFill>
                   <a:srgbClr val="656B70"/>
@@ -8865,6 +8985,7 @@
           <a:lstStyle xmlns:a="http://schemas.openxmlformats.org/drawingml/2006/main"/>
           <a:p xmlns:a="http://schemas.openxmlformats.org/drawingml/2006/main">
             <a:pPr algn="l">
+              <a:buNone/>
               <a:defRPr sz="1350" b="0">
                 <a:solidFill>
                   <a:srgbClr val="656B70"/>
@@ -8915,6 +9036,7 @@
           <a:lstStyle xmlns:a="http://schemas.openxmlformats.org/drawingml/2006/main"/>
           <a:p xmlns:a="http://schemas.openxmlformats.org/drawingml/2006/main">
             <a:pPr algn="l">
+              <a:buNone/>
               <a:defRPr sz="1350" b="0">
                 <a:solidFill>
                   <a:srgbClr val="656B70"/>
@@ -8994,6 +9116,7 @@
           <a:lstStyle xmlns:a="http://schemas.openxmlformats.org/drawingml/2006/main"/>
           <a:p xmlns:a="http://schemas.openxmlformats.org/drawingml/2006/main">
             <a:pPr algn="l">
+              <a:buNone/>
               <a:defRPr sz="1125" b="1">
                 <a:solidFill>
                   <a:srgbClr val="345995"/>
@@ -9044,6 +9167,7 @@
           <a:lstStyle xmlns:a="http://schemas.openxmlformats.org/drawingml/2006/main"/>
           <a:p xmlns:a="http://schemas.openxmlformats.org/drawingml/2006/main">
             <a:pPr algn="l">
+              <a:buNone/>
               <a:defRPr sz="3450" b="1">
                 <a:solidFill>
                   <a:srgbClr val="202428"/>
@@ -9061,6 +9185,7 @@
           </a:p>
           <a:p xmlns:a="http://schemas.openxmlformats.org/drawingml/2006/main">
             <a:pPr algn="l">
+              <a:buNone/>
               <a:defRPr sz="3450" b="1">
                 <a:solidFill>
                   <a:srgbClr val="202428"/>
@@ -9142,6 +9267,7 @@
           <a:lstStyle xmlns:a="http://schemas.openxmlformats.org/drawingml/2006/main"/>
           <a:p xmlns:a="http://schemas.openxmlformats.org/drawingml/2006/main">
             <a:pPr algn="l">
+              <a:buNone/>
               <a:defRPr sz="1650" b="0">
                 <a:solidFill>
                   <a:srgbClr val="656B70"/>
@@ -9192,6 +9318,7 @@
           <a:lstStyle xmlns:a="http://schemas.openxmlformats.org/drawingml/2006/main"/>
           <a:p xmlns:a="http://schemas.openxmlformats.org/drawingml/2006/main">
             <a:pPr algn="l">
+              <a:buNone/>
               <a:defRPr sz="1875" b="1">
                 <a:solidFill>
                   <a:srgbClr val="202428"/>
@@ -9209,6 +9336,7 @@
           </a:p>
           <a:p xmlns:a="http://schemas.openxmlformats.org/drawingml/2006/main">
             <a:pPr algn="l">
+              <a:buNone/>
               <a:defRPr sz="1875" b="1">
                 <a:solidFill>
                   <a:srgbClr val="202428"/>
@@ -9292,6 +9420,7 @@
           <a:lstStyle xmlns:a="http://schemas.openxmlformats.org/drawingml/2006/main"/>
           <a:p xmlns:a="http://schemas.openxmlformats.org/drawingml/2006/main">
             <a:pPr algn="l">
+              <a:buNone/>
               <a:defRPr sz="2550" b="1">
                 <a:solidFill>
                   <a:srgbClr val="345995"/>
@@ -9342,6 +9471,7 @@
           <a:lstStyle xmlns:a="http://schemas.openxmlformats.org/drawingml/2006/main"/>
           <a:p xmlns:a="http://schemas.openxmlformats.org/drawingml/2006/main">
             <a:pPr algn="l">
+              <a:buNone/>
               <a:defRPr sz="1350" b="0">
                 <a:solidFill>
                   <a:srgbClr val="656B70"/>
@@ -9359,6 +9489,7 @@
           </a:p>
           <a:p xmlns:a="http://schemas.openxmlformats.org/drawingml/2006/main">
             <a:pPr algn="l">
+              <a:buNone/>
               <a:defRPr sz="1350" b="0">
                 <a:solidFill>
                   <a:srgbClr val="656B70"/>
@@ -9376,6 +9507,7 @@
           </a:p>
           <a:p xmlns:a="http://schemas.openxmlformats.org/drawingml/2006/main">
             <a:pPr algn="l">
+              <a:buNone/>
               <a:defRPr sz="1350" b="0">
                 <a:solidFill>
                   <a:srgbClr val="656B70"/>
@@ -9426,6 +9558,7 @@
           <a:lstStyle xmlns:a="http://schemas.openxmlformats.org/drawingml/2006/main"/>
           <a:p xmlns:a="http://schemas.openxmlformats.org/drawingml/2006/main">
             <a:pPr algn="l">
+              <a:buNone/>
               <a:defRPr sz="1350" b="0">
                 <a:solidFill>
                   <a:srgbClr val="656B70"/>

</xml_diff>

<commit_message>
docs: reflect GitHub publication
</commit_message>
<xml_diff>
--- a/docs/presentation/invoice-manager-engineering-case-study.pptx
+++ b/docs/presentation/invoice-manager-engineering-case-study.pptx
@@ -2,21 +2,21 @@
 <file path=ppt/presentation.xml><?xml version="1.0" encoding="utf-8"?>
 <p:presentation xmlns:p="http://schemas.openxmlformats.org/presentationml/2006/main">
   <p:sldMasterIdLst>
-    <p:sldMasterId xmlns:r="http://schemas.openxmlformats.org/officeDocument/2006/relationships" id="2147483648" r:id="Rcbdbd639cfce4d07"/>
+    <p:sldMasterId xmlns:r="http://schemas.openxmlformats.org/officeDocument/2006/relationships" id="2147483648" r:id="Rac1989845f2d446d"/>
   </p:sldMasterIdLst>
   <p:notesMasterIdLst>
-    <p:notesMasterId xmlns:r="http://schemas.openxmlformats.org/officeDocument/2006/relationships" r:id="R20854748620a4eba"/>
+    <p:notesMasterId xmlns:r="http://schemas.openxmlformats.org/officeDocument/2006/relationships" r:id="Ref568f2cc0d04373"/>
   </p:notesMasterIdLst>
   <p:sldIdLst>
-    <p:sldId xmlns:r="http://schemas.openxmlformats.org/officeDocument/2006/relationships" id="256" r:id="R4fc1a75c82c041bb"/>
-    <p:sldId xmlns:r="http://schemas.openxmlformats.org/officeDocument/2006/relationships" id="257" r:id="R353f0e0bbd9e46f4"/>
-    <p:sldId xmlns:r="http://schemas.openxmlformats.org/officeDocument/2006/relationships" id="258" r:id="Re409f487fdfe41d8"/>
-    <p:sldId xmlns:r="http://schemas.openxmlformats.org/officeDocument/2006/relationships" id="259" r:id="R708edf85cdd64c67"/>
-    <p:sldId xmlns:r="http://schemas.openxmlformats.org/officeDocument/2006/relationships" id="260" r:id="R0e130459289d4a63"/>
-    <p:sldId xmlns:r="http://schemas.openxmlformats.org/officeDocument/2006/relationships" id="261" r:id="R8da75d355ca54b52"/>
-    <p:sldId xmlns:r="http://schemas.openxmlformats.org/officeDocument/2006/relationships" id="262" r:id="Rddd9d0306d1a4707"/>
-    <p:sldId xmlns:r="http://schemas.openxmlformats.org/officeDocument/2006/relationships" id="263" r:id="R44110dfdd83b428b"/>
-    <p:sldId xmlns:r="http://schemas.openxmlformats.org/officeDocument/2006/relationships" id="264" r:id="Ra3839e56fbf345f9"/>
+    <p:sldId xmlns:r="http://schemas.openxmlformats.org/officeDocument/2006/relationships" id="256" r:id="R04b0bbb14e6246b4"/>
+    <p:sldId xmlns:r="http://schemas.openxmlformats.org/officeDocument/2006/relationships" id="257" r:id="R3f568837008b47fc"/>
+    <p:sldId xmlns:r="http://schemas.openxmlformats.org/officeDocument/2006/relationships" id="258" r:id="Rb742d4ef715c41e2"/>
+    <p:sldId xmlns:r="http://schemas.openxmlformats.org/officeDocument/2006/relationships" id="259" r:id="R380e8f76c5104a26"/>
+    <p:sldId xmlns:r="http://schemas.openxmlformats.org/officeDocument/2006/relationships" id="260" r:id="R23e81c85ab6948bf"/>
+    <p:sldId xmlns:r="http://schemas.openxmlformats.org/officeDocument/2006/relationships" id="261" r:id="Rf5e9ff63aa8b4222"/>
+    <p:sldId xmlns:r="http://schemas.openxmlformats.org/officeDocument/2006/relationships" id="262" r:id="Rac60083f316c4f4e"/>
+    <p:sldId xmlns:r="http://schemas.openxmlformats.org/officeDocument/2006/relationships" id="263" r:id="R2b8e5d3729244215"/>
+    <p:sldId xmlns:r="http://schemas.openxmlformats.org/officeDocument/2006/relationships" id="264" r:id="R594b0c47e45844e8"/>
   </p:sldIdLst>
   <p:sldSz cx="12192000" cy="6858000"/>
   <p:notesSz cx="6858000" cy="9144000"/>
@@ -1143,7 +1143,7 @@
   </p:cSld>
   <p:clrMap bg1="lt1" tx1="dk1" bg2="lt2" tx2="dk2" accent1="accent1" accent2="accent2" accent3="accent3" accent4="accent4" accent5="accent5" accent6="accent6" hlink="hlink" folHlink="folHlink"/>
   <p:sldLayoutIdLst>
-    <p:sldLayoutId xmlns:r="http://schemas.openxmlformats.org/officeDocument/2006/relationships" id="2147483649" r:id="Rf02dde1895e4421b"/>
+    <p:sldLayoutId xmlns:r="http://schemas.openxmlformats.org/officeDocument/2006/relationships" id="2147483649" r:id="Rb00d935b5b3b4a91"/>
   </p:sldLayoutIdLst>
   <p:txStyles>
     <p:titleStyle>
@@ -2071,7 +2071,7 @@
           <p:nvPr/>
         </p:nvPicPr>
         <p:blipFill>
-          <a:blip xmlns:r="http://schemas.openxmlformats.org/officeDocument/2006/relationships" xmlns:a="http://schemas.openxmlformats.org/drawingml/2006/main" r:embed="Ra361bdfa6bf04188"/>
+          <a:blip xmlns:r="http://schemas.openxmlformats.org/officeDocument/2006/relationships" xmlns:a="http://schemas.openxmlformats.org/drawingml/2006/main" r:embed="Re40b6ead7c944553"/>
           <a:stretch xmlns:a="http://schemas.openxmlformats.org/drawingml/2006/main"/>
         </p:blipFill>
         <p:spPr>
@@ -6063,7 +6063,7 @@
           <p:nvPr/>
         </p:nvPicPr>
         <p:blipFill>
-          <a:blip xmlns:r="http://schemas.openxmlformats.org/officeDocument/2006/relationships" xmlns:a="http://schemas.openxmlformats.org/drawingml/2006/main" r:embed="Reb88037ca98e46ba"/>
+          <a:blip xmlns:r="http://schemas.openxmlformats.org/officeDocument/2006/relationships" xmlns:a="http://schemas.openxmlformats.org/drawingml/2006/main" r:embed="Rdffdb0cb5df44c71"/>
           <a:stretch xmlns:a="http://schemas.openxmlformats.org/drawingml/2006/main"/>
         </p:blipFill>
         <p:spPr>
@@ -6686,7 +6686,7 @@
           <p:nvPr/>
         </p:nvPicPr>
         <p:blipFill>
-          <a:blip xmlns:r="http://schemas.openxmlformats.org/officeDocument/2006/relationships" xmlns:a="http://schemas.openxmlformats.org/drawingml/2006/main" r:embed="Rc715718d44d4496b"/>
+          <a:blip xmlns:r="http://schemas.openxmlformats.org/officeDocument/2006/relationships" xmlns:a="http://schemas.openxmlformats.org/drawingml/2006/main" r:embed="Re4f391d47fa949eb"/>
           <a:srcRect xmlns:a="http://schemas.openxmlformats.org/drawingml/2006/main" l="12000" t="6000" r="1000" b="1000"/>
           <a:stretch xmlns:a="http://schemas.openxmlformats.org/drawingml/2006/main">
             <a:fillRect l="0" t="0" r="0" b="0"/>
@@ -7253,7 +7253,7 @@
           <p:nvPr/>
         </p:nvPicPr>
         <p:blipFill>
-          <a:blip xmlns:r="http://schemas.openxmlformats.org/officeDocument/2006/relationships" xmlns:a="http://schemas.openxmlformats.org/drawingml/2006/main" r:embed="R482f72d513464761"/>
+          <a:blip xmlns:r="http://schemas.openxmlformats.org/officeDocument/2006/relationships" xmlns:a="http://schemas.openxmlformats.org/drawingml/2006/main" r:embed="R3a8c9540872a42bc"/>
           <a:srcRect xmlns:a="http://schemas.openxmlformats.org/drawingml/2006/main" l="0" t="0" r="0" b="0"/>
           <a:stretch xmlns:a="http://schemas.openxmlformats.org/drawingml/2006/main"/>
         </p:blipFill>
@@ -9454,8 +9454,8 @@
         </p:nvSpPr>
         <p:spPr>
           <a:xfrm xmlns:a="http://schemas.openxmlformats.org/drawingml/2006/main">
-            <a:off x="9296400" y="4343400"/>
-            <a:ext cx="1905000" cy="742950"/>
+            <a:off x="9296400" y="4286250"/>
+            <a:ext cx="2000250" cy="876300"/>
           </a:xfrm>
           <a:prstGeom xmlns:a="http://schemas.openxmlformats.org/drawingml/2006/main" prst="rect">
             <a:avLst/>
@@ -9520,7 +9520,7 @@
                   <a:srgbClr val="656B70"/>
                 </a:solidFill>
               </a:rPr>
-              <a:t>GitHub-ready</a:t>
+              <a:t>Public GitHub repository</a:t>
             </a:r>
           </a:p>
         </p:txBody>
@@ -9541,8 +9541,8 @@
         </p:nvSpPr>
         <p:spPr>
           <a:xfrm xmlns:a="http://schemas.openxmlformats.org/drawingml/2006/main">
-            <a:off x="685800" y="5867400"/>
-            <a:ext cx="8572500" cy="304800"/>
+            <a:off x="685800" y="5791200"/>
+            <a:ext cx="10477500" cy="457200"/>
           </a:xfrm>
           <a:prstGeom xmlns:a="http://schemas.openxmlformats.org/drawingml/2006/main" prst="rect">
             <a:avLst/>
@@ -9571,7 +9571,7 @@
                   <a:srgbClr val="656B70"/>
                 </a:solidFill>
               </a:rPr>
-              <a:t>Source, screenshots, ADRs, release notes and verified package prepared for publication.</a:t>
+              <a:t>Source, screenshots, ADRs, release notes and verified Windows package available on GitHub.</a:t>
             </a:r>
           </a:p>
         </p:txBody>

</xml_diff>